<commit_message>
feat: update official metadata, blind report against rubric traps, and save executed notebook
</commit_message>
<xml_diff>
--- a/PRESENTACION_CLASE_5MIN.pptx
+++ b/PRESENTACION_CLASE_5MIN.pptx
@@ -4014,16 +4014,20 @@
           <a:p>
             <a:pPr>
               <a:spcBef>
-                <a:spcPts val="2400"/>
+                <a:spcPts val="2200"/>
               </a:spcBef>
-              <a:defRPr sz="1300" b="1">
+              <a:defRPr sz="1200" b="1">
                 <a:solidFill>
                   <a:srgbClr val="FFFFFF"/>
                 </a:solidFill>
               </a:defRPr>
             </a:pPr>
             <a:r>
-              <a:t>Expositores: Audric Rosario &amp; Orlando Benítez | Tiempo Estimado: 5 Minutos</a:t>
+              <a:t>Facilitador: Luis Eduardo Bayonet Robles</a:t>
+            </a:r>
+            <a:br/>
+            <a:r>
+              <a:t>Expositores: Audric André Rosario Rosario (100089140) &amp; Orlando Benítez Ventura (100090873) | Tiempo: 5 Minutos</a:t>
             </a:r>
           </a:p>
         </p:txBody>

</xml_diff>